<commit_message>
content(fifty-states): semitruckmatch 2026-06-09T04 UTC
</commit_message>
<xml_diff>
--- a/public/blog/presentations/es/tractor-trailer-injury-in-houston-texas-legal-steps-2026.pptx
+++ b/public/blog/presentations/es/tractor-trailer-injury-in-houston-texas-legal-steps-2026.pptx
@@ -515,7 +515,7 @@
           <a:lstStyle/>
           <a:p>
             <a:r>
-              <a:t>Educational presentation for Tractor-Trailer Injury in Houston, Texas: Legal Steps (2026). Full guide: https://www.wreckmatch.com/es/blog/tractor-trailer-injury-in-houston-texas-legal-steps-2026. WreckMatch LLC legal referral service, not a law firm. WreckMatch LLC — legal referral service, not a law firm. Educational only. 800+ participating law firms. Call 855 WRECKMATCH. Reviewed for legal context by Judge Roy Waddell.</a:t>
+              <a:t>Educational presentation for Tractor-Trailer Injury in Houston, Texas: Legal Steps (2026). Full guide: https://www.wreckmatch.com/es/blog/tractor-trailer-injury-in-houston-texas-legal-steps-2026. WreckMatch LLC legal referral service, not a law firm. WreckMatch LLC — legal referral service, not a law firm. Educational only. 800+ participating law firms. Call 855 WRECKMATCH. Reviewed for legal context by Hon. Ret. Judge Roy Waddell.</a:t>
             </a:r>
           </a:p>
         </p:txBody>
@@ -591,7 +591,7 @@
           <a:p/>
           <a:p>
             <a:r>
-              <a:t>En todo Texas, el seguro mínimo es 30/60/25. Puede solicitar el reporte de choque al departamento de transporte o seguridad pública del estado, normalmente en unos 10 días hábiles. WreckMatch LLC — legal referral service, not a law firm. Educational only. 800+ participating law firms. Call 855 WRECKMATCH. Reviewed for legal context by Judge Roy Waddell.</a:t>
+              <a:t>En todo Texas, el seguro mínimo es 30/60/25. Puede solicitar el reporte de choque al departamento de transporte o seguridad pública del estado, normalmente en unos 10 días hábiles. WreckMatch LLC — legal referral service, not a law firm. Educational only. 800+ participating law firms. Call 855 WRECKMATCH. Reviewed for legal context by Hon. Ret. Judge Roy Waddell.</a:t>
             </a:r>
           </a:p>
         </p:txBody>
@@ -679,7 +679,7 @@
           <a:p/>
           <a:p>
             <a:r>
-              <a:t>WreckMatch LLC es un servicio de referencia legal, no un bufete. No cobramos a consumidores. Este artículo es información general, no asesoría legal para su caso. WreckMatch LLC — legal referral service, not a law firm. Educational only. 800+ participating law firms. Call 855 WRECKMATCH. Reviewed for legal context by Judge Roy Waddell.</a:t>
+              <a:t>WreckMatch LLC es un servicio de referencia legal, no un bufete. No cobramos a consumidores. Este artículo es información general, no asesoría legal para su caso. WreckMatch LLC — legal referral service, not a law firm. Educational only. 800+ participating law firms. Call 855 WRECKMATCH. Reviewed for legal context by Hon. Ret. Judge Roy Waddell.</a:t>
             </a:r>
           </a:p>
         </p:txBody>
@@ -749,7 +749,7 @@
           <a:lstStyle/>
           <a:p>
             <a:r>
-              <a:t>Preguntas frecuentes WreckMatch LLC — legal referral service, not a law firm. Educational only. 800+ participating law firms. Call 855 WRECKMATCH. Reviewed for legal context by Judge Roy Waddell.</a:t>
+              <a:t>Preguntas frecuentes WreckMatch LLC — legal referral service, not a law firm. Educational only. 800+ participating law firms. Call 855 WRECKMATCH. Reviewed for legal context by Hon. Ret. Judge Roy Waddell.</a:t>
             </a:r>
           </a:p>
         </p:txBody>
@@ -819,7 +819,7 @@
           <a:lstStyle/>
           <a:p>
             <a:r>
-              <a:t>Emparejamiento con abogado con licencia WreckMatch LLC — legal referral service, not a law firm. Educational only. 800+ participating law firms. Call 855 WRECKMATCH. Reviewed for legal context by Judge Roy Waddell.</a:t>
+              <a:t>Emparejamiento con abogado con licencia WreckMatch LLC — legal referral service, not a law firm. Educational only. 800+ participating law firms. Call 855 WRECKMATCH. Reviewed for legal context by Hon. Ret. Judge Roy Waddell.</a:t>
             </a:r>
           </a:p>
         </p:txBody>
@@ -889,7 +889,7 @@
           <a:lstStyle/>
           <a:p>
             <a:r>
-              <a:t>Revisado para contexto legal WreckMatch LLC — legal referral service, not a law firm. Educational only. 800+ participating law firms. Call 855 WRECKMATCH. Reviewed for legal context by Judge Roy Waddell.</a:t>
+              <a:t>Revisado para contexto legal WreckMatch LLC — legal referral service, not a law firm. Educational only. 800+ participating law firms. Call 855 WRECKMATCH. Reviewed for legal context by Hon. Ret. Judge Roy Waddell.</a:t>
             </a:r>
           </a:p>
         </p:txBody>
@@ -959,7 +959,7 @@
           <a:lstStyle/>
           <a:p>
             <a:r>
-              <a:t>Importante — lea primero WreckMatch LLC — legal referral service, not a law firm. Educational only. 800+ participating law firms. Call 855 WRECKMATCH. Reviewed for legal context by Judge Roy Waddell.</a:t>
+              <a:t>Importante — lea primero WreckMatch LLC — legal referral service, not a law firm. Educational only. 800+ participating law firms. Call 855 WRECKMATCH. Reviewed for legal context by Hon. Ret. Judge Roy Waddell.</a:t>
             </a:r>
           </a:p>
         </p:txBody>
@@ -1029,7 +1029,7 @@
           <a:lstStyle/>
           <a:p>
             <a:r>
-              <a:t>Datos rápidos de Texas: plazo 2 años · regla Modified 51% · seguro mínimo 30/60/25. WreckMatch LLC — legal referral service, not a law firm. Educational only. 800+ participating law firms. Call 855 WRECKMATCH. Reviewed for legal context by Judge Roy Waddell.</a:t>
+              <a:t>Datos rápidos de Texas: plazo 2 años · regla Modified 51% · seguro mínimo 30/60/25. WreckMatch LLC — legal referral service, not a law firm. Educational only. 800+ participating law firms. Call 855 WRECKMATCH. Reviewed for legal context by Hon. Ret. Judge Roy Waddell.</a:t>
             </a:r>
           </a:p>
         </p:txBody>
@@ -1126,7 +1126,7 @@
           <a:p/>
           <a:p>
             <a:r>
-              <a:t>En resumen: Datos rápidos de Texas: plazo 2 años · regla Modified 51% · seguro mínimo 30/60/25. WreckMatch LLC — legal referral service, not a law firm. Educational only. 800+ participating law firms. Call 855 WRECKMATCH. Reviewed for legal context by Judge Roy Waddell.</a:t>
+              <a:t>En resumen: Datos rápidos de Texas: plazo 2 años · regla Modified 51% · seguro mínimo 30/60/25. WreckMatch LLC — legal referral service, not a law firm. Educational only. 800+ participating law firms. Call 855 WRECKMATCH. Reviewed for legal context by Hon. Ret. Judge Roy Waddell.</a:t>
             </a:r>
           </a:p>
         </p:txBody>
@@ -1208,7 +1208,7 @@
           <a:p/>
           <a:p>
             <a:r>
-              <a:t>Texas es un estado de culpa (“at-fault”): el seguro del responsable es la fuente principal de recuperación una vez establecida la responsabilidad. In Texas, deadlines and insurance rules can change how claims are handled. Document medical care early and avoid recorded statements without guidance. Rangos publicados de recuperación en Texas suelen situarse alrededor de $22k–$180k — describen casos pasados, no una promesa para el suyo. WreckMatch LLC — legal referral service, not a law firm. Educational only. 800+ participating law firms. Call 855 WRECKMATCH. Reviewed for legal context by Judge Roy Waddell.</a:t>
+              <a:t>Texas es un estado de culpa (“at-fault”): el seguro del responsable es la fuente principal de recuperación una vez establecida la responsabilidad. In Texas, deadlines and insurance rules can change how claims are handled. Document medical care early and avoid recorded statements without guidance. Rangos publicados de recuperación en Texas suelen situarse alrededor de $22k–$180k — describen casos pasados, no una promesa para el suyo. WreckMatch LLC — legal referral service, not a law firm. Educational only. 800+ participating law firms. Call 855 WRECKMATCH. Reviewed for legal context by Hon. Ret. Judge Roy Waddell.</a:t>
             </a:r>
           </a:p>
         </p:txBody>
@@ -1335,7 +1335,7 @@
           </a:p>
           <a:p>
             <a:r>
-              <a:t>10. No firme nada que diga “liberación”, “renuncia” o “autorización médica” amplia sin abogado. WreckMatch LLC — legal referral service, not a law firm. Educational only. 800+ participating law firms. Call 855 WRECKMATCH. Reviewed for legal context by Judge Roy Waddell.</a:t>
+              <a:t>10. No firme nada que diga “liberación”, “renuncia” o “autorización médica” amplia sin abogado. WreckMatch LLC — legal referral service, not a law firm. Educational only. 800+ participating law firms. Call 855 WRECKMATCH. Reviewed for legal context by Hon. Ret. Judge Roy Waddell.</a:t>
             </a:r>
           </a:p>
         </p:txBody>
@@ -1417,7 +1417,7 @@
           <a:p/>
           <a:p>
             <a:r>
-              <a:t>Identifique a todos los demandados posibles: conductor, empleador, arrendador del remolque, fabricante del equipo y terceros de carga. WreckMatch LLC — legal referral service, not a law firm. Educational only. 800+ participating law firms. Call 855 WRECKMATCH. Reviewed for legal context by Judge Roy Waddell.</a:t>
+              <a:t>Identifique a todos los demandados posibles: conductor, empleador, arrendador del remolque, fabricante del equipo y terceros de carga. WreckMatch LLC — legal referral service, not a law firm. Educational only. 800+ participating law firms. Call 855 WRECKMATCH. Reviewed for legal context by Hon. Ret. Judge Roy Waddell.</a:t>
             </a:r>
           </a:p>
         </p:txBody>
@@ -1499,7 +1499,7 @@
           <a:p/>
           <a:p>
             <a:r>
-              <a:t>Quien garantice un rango sin revisar su expediente no está siendo honesto. La estimación creíble viene de un abogado de lesiones personales con licencia en su estado. WreckMatch LLC — legal referral service, not a law firm. Educational only. 800+ participating law firms. Call 855 WRECKMATCH. Reviewed for legal context by Judge Roy Waddell.</a:t>
+              <a:t>Quien garantice un rango sin revisar su expediente no está siendo honesto. La estimación creíble viene de un abogado de lesiones personales con licencia en su estado. WreckMatch LLC — legal referral service, not a law firm. Educational only. 800+ participating law firms. Call 855 WRECKMATCH. Reviewed for legal context by Hon. Ret. Judge Roy Waddell.</a:t>
             </a:r>
           </a:p>
         </p:txBody>
@@ -1610,7 +1610,7 @@
           </a:p>
           <a:p>
             <a:r>
-              <a:t>8. Hospitalización, cirugía o restricción permanente. WreckMatch LLC — legal referral service, not a law firm. Educational only. 800+ participating law firms. Call 855 WRECKMATCH. Reviewed for legal context by Judge Roy Waddell.</a:t>
+              <a:t>8. Hospitalización, cirugía o restricción permanente. WreckMatch LLC — legal referral service, not a law firm. Educational only. 800+ participating law firms. Call 855 WRECKMATCH. Reviewed for legal context by Hon. Ret. Judge Roy Waddell.</a:t>
             </a:r>
           </a:p>
         </p:txBody>
@@ -4704,7 +4704,7 @@
               </a:defRPr>
             </a:pPr>
             <a:r>
-              <a:t>Truck Accidents · Texas · 2026-05-23</a:t>
+              <a:t>Truck Accidents · Texas · 2026-06-09</a:t>
             </a:r>
           </a:p>
         </p:txBody>

</xml_diff>